<commit_message>
updated the pitch deck, readme and added the ai we used
</commit_message>
<xml_diff>
--- a/deliverables/CoverIQ_Pitch_Deck.pptx
+++ b/deliverables/CoverIQ_Pitch_Deck.pptx
@@ -5679,7 +5679,7 @@
                 <a:ea typeface="Segoe UI" panose="020B0502040204020203"/>
                 <a:cs typeface="Segoe UI" panose="020B0502040204020203"/>
               </a:rPr>
-              <a:t> sometimes recieve products that do not relate to them or it doesn and its not just the tight time</a:t>
+              <a:t> sometimes recieve products that do not relate to them or it does and its not just the right time</a:t>
             </a:r>
             <a:endParaRPr lang="en-US" sz="2025" b="0">
               <a:solidFill>
@@ -8445,28 +8445,19 @@
                 <a:ea typeface="Segoe UI" panose="020B0502040204020203"/>
                 <a:cs typeface="Segoe UI" panose="020B0502040204020203"/>
               </a:rPr>
-              <a:t>BANK OR</a:t>
+              <a:t>BANK </a:t>
             </a:r>
-            <a:endParaRPr sz="1650" b="1">
-              <a:solidFill>
-                <a:srgbClr val="FFFFFF"/>
-              </a:solidFill>
-              <a:latin typeface="Segoe UI" panose="020B0502040204020203"/>
-              <a:ea typeface="Segoe UI" panose="020B0502040204020203"/>
-              <a:cs typeface="Segoe UI" panose="020B0502040204020203"/>
-            </a:endParaRPr>
-          </a:p>
-          <a:p>
-            <a:pPr algn="ctr">
-              <a:defRPr sz="1650" b="1">
-                <a:solidFill>
-                  <a:srgbClr val="FFFFFF"/>
-                </a:solidFill>
-                <a:latin typeface="Segoe UI" panose="020B0502040204020203"/>
-                <a:ea typeface="Segoe UI" panose="020B0502040204020203"/>
-                <a:cs typeface="Segoe UI" panose="020B0502040204020203"/>
-              </a:defRPr>
-            </a:pPr>
+            <a:r>
+              <a:rPr lang="en-US" sz="1650" b="1">
+                <a:solidFill>
+                  <a:srgbClr val="FFFFFF"/>
+                </a:solidFill>
+                <a:latin typeface="Segoe UI" panose="020B0502040204020203"/>
+                <a:ea typeface="Segoe UI" panose="020B0502040204020203"/>
+                <a:cs typeface="Segoe UI" panose="020B0502040204020203"/>
+              </a:rPr>
+              <a:t>/ </a:t>
+            </a:r>
             <a:r>
               <a:rPr sz="1650" b="1">
                 <a:solidFill>
@@ -8717,17 +8708,27 @@
                 <a:cs typeface="Segoe UI" panose="020B0502040204020203"/>
               </a:defRPr>
             </a:pPr>
+            <a:br>
+              <a:rPr>
+                <a:sym typeface="+mn-ea"/>
+              </a:rPr>
+            </a:br>
+            <a:br>
+              <a:rPr>
+                <a:sym typeface="+mn-ea"/>
+              </a:rPr>
+            </a:br>
             <a:r>
-              <a:rPr sz="1800" b="1">
-                <a:solidFill>
-                  <a:srgbClr val="0B1727"/>
-                </a:solidFill>
-                <a:latin typeface="Segoe UI" panose="020B0502040204020203"/>
-                <a:ea typeface="Segoe UI" panose="020B0502040204020203"/>
-                <a:cs typeface="Segoe UI" panose="020B0502040204020203"/>
+              <a:rPr>
+                <a:sym typeface="+mn-ea"/>
               </a:rPr>
               <a:t>COVERIQ</a:t>
             </a:r>
+            <a:br>
+              <a:rPr>
+                <a:sym typeface="+mn-ea"/>
+              </a:rPr>
+            </a:br>
             <a:endParaRPr sz="1800" b="1">
               <a:solidFill>
                 <a:srgbClr val="0B1727"/>
@@ -8748,13 +8749,14 @@
                 <a:cs typeface="Segoe UI" panose="020B0502040204020203"/>
               </a:defRPr>
             </a:pPr>
-            <a:endParaRPr sz="1800" b="1">
+            <a:endParaRPr b="1">
               <a:solidFill>
                 <a:srgbClr val="0B1727"/>
               </a:solidFill>
               <a:latin typeface="Segoe UI" panose="020B0502040204020203"/>
               <a:ea typeface="Segoe UI" panose="020B0502040204020203"/>
               <a:cs typeface="Segoe UI" panose="020B0502040204020203"/>
+              <a:sym typeface="+mn-ea"/>
             </a:endParaRPr>
           </a:p>
         </p:txBody>
@@ -15215,7 +15217,7 @@
               </a:defRPr>
             </a:pPr>
             <a:r>
-              <a:rPr lang="en-US" sz="3600" b="1">
+              <a:rPr lang="en-US" altLang="en-GB" sz="3600" b="1">
                 <a:solidFill>
                   <a:srgbClr val="0B1727"/>
                 </a:solidFill>
@@ -15223,31 +15225,9 @@
                 <a:ea typeface="Segoe UI" panose="020B0502040204020203"/>
                 <a:cs typeface="Segoe UI" panose="020B0502040204020203"/>
               </a:rPr>
-              <a:t>AN</a:t>
+              <a:t>An SDK that integrates with their system.</a:t>
             </a:r>
-            <a:r>
-              <a:rPr sz="3600" b="1">
-                <a:solidFill>
-                  <a:srgbClr val="0B1727"/>
-                </a:solidFill>
-                <a:latin typeface="Segoe UI" panose="020B0502040204020203"/>
-                <a:ea typeface="Segoe UI" panose="020B0502040204020203"/>
-                <a:cs typeface="Segoe UI" panose="020B0502040204020203"/>
-              </a:rPr>
-              <a:t> SDK</a:t>
-            </a:r>
-            <a:r>
-              <a:rPr lang="en-US" sz="3600" b="1">
-                <a:solidFill>
-                  <a:srgbClr val="0B1727"/>
-                </a:solidFill>
-                <a:latin typeface="Segoe UI" panose="020B0502040204020203"/>
-                <a:ea typeface="Segoe UI" panose="020B0502040204020203"/>
-                <a:cs typeface="Segoe UI" panose="020B0502040204020203"/>
-              </a:rPr>
-              <a:t> PLUG INTO THEIR SYETEM</a:t>
-            </a:r>
-            <a:endParaRPr lang="en-US" sz="3600" b="1">
+            <a:endParaRPr lang="en-US" altLang="en-GB" sz="3600" b="1">
               <a:solidFill>
                 <a:srgbClr val="0B1727"/>
               </a:solidFill>
@@ -15888,7 +15868,11 @@
           <p:cNvSpPr>
             <a:spLocks noGrp="1"/>
           </p:cNvSpPr>
-          <p:nvPr/>
+          <p:nvPr>
+            <p:custDataLst>
+              <p:tags r:id="rId1"/>
+            </p:custDataLst>
+          </p:nvPr>
         </p:nvSpPr>
         <p:spPr>
           <a:xfrm>
@@ -15913,7 +15897,11 @@
           <p:cNvSpPr>
             <a:spLocks noGrp="1"/>
           </p:cNvSpPr>
-          <p:nvPr/>
+          <p:nvPr>
+            <p:custDataLst>
+              <p:tags r:id="rId2"/>
+            </p:custDataLst>
+          </p:nvPr>
         </p:nvSpPr>
         <p:spPr>
           <a:xfrm>
@@ -16074,7 +16062,11 @@
           <p:cNvSpPr>
             <a:spLocks noGrp="1"/>
           </p:cNvSpPr>
-          <p:nvPr/>
+          <p:nvPr>
+            <p:custDataLst>
+              <p:tags r:id="rId3"/>
+            </p:custDataLst>
+          </p:nvPr>
         </p:nvSpPr>
         <p:spPr>
           <a:xfrm>
@@ -16233,11 +16225,15 @@
           <p:cNvSpPr>
             <a:spLocks noGrp="1"/>
           </p:cNvSpPr>
-          <p:nvPr/>
+          <p:nvPr>
+            <p:custDataLst>
+              <p:tags r:id="rId4"/>
+            </p:custDataLst>
+          </p:nvPr>
         </p:nvSpPr>
         <p:spPr>
           <a:xfrm>
-            <a:off x="762000" y="4895850"/>
+            <a:off x="762000" y="5085080"/>
             <a:ext cx="3048000" cy="647700"/>
           </a:xfrm>
           <a:prstGeom prst="rect">
@@ -16365,7 +16361,7 @@
               </a:defRPr>
             </a:pPr>
             <a:r>
-              <a:rPr sz="1800" b="1">
+              <a:rPr lang="en-US" altLang="en-GB" sz="1800" b="1">
                 <a:solidFill>
                   <a:srgbClr val="0B1727"/>
                 </a:solidFill>
@@ -16373,40 +16369,9 @@
                 <a:ea typeface="Segoe UI" panose="020B0502040204020203"/>
                 <a:cs typeface="Segoe UI" panose="020B0502040204020203"/>
               </a:rPr>
-              <a:t>Integration</a:t>
+              <a:t>Define the SDK interface, data format and configurable product catalogue.</a:t>
             </a:r>
-            <a:endParaRPr sz="1800" b="1">
-              <a:solidFill>
-                <a:srgbClr val="0B1727"/>
-              </a:solidFill>
-              <a:latin typeface="Segoe UI" panose="020B0502040204020203"/>
-              <a:ea typeface="Segoe UI" panose="020B0502040204020203"/>
-              <a:cs typeface="Segoe UI" panose="020B0502040204020203"/>
-            </a:endParaRPr>
-          </a:p>
-          <a:p>
-            <a:pPr algn="ctr">
-              <a:defRPr sz="1800" b="1">
-                <a:solidFill>
-                  <a:srgbClr val="0B1727"/>
-                </a:solidFill>
-                <a:latin typeface="Segoe UI" panose="020B0502040204020203"/>
-                <a:ea typeface="Segoe UI" panose="020B0502040204020203"/>
-                <a:cs typeface="Segoe UI" panose="020B0502040204020203"/>
-              </a:defRPr>
-            </a:pPr>
-            <a:r>
-              <a:rPr sz="1800" b="1">
-                <a:solidFill>
-                  <a:srgbClr val="0B1727"/>
-                </a:solidFill>
-                <a:latin typeface="Segoe UI" panose="020B0502040204020203"/>
-                <a:ea typeface="Segoe UI" panose="020B0502040204020203"/>
-                <a:cs typeface="Segoe UI" panose="020B0502040204020203"/>
-              </a:rPr>
-              <a:t>+ catalogue</a:t>
-            </a:r>
-            <a:endParaRPr sz="1800" b="1">
+            <a:endParaRPr lang="en-US" altLang="en-GB" sz="1800" b="1">
               <a:solidFill>
                 <a:srgbClr val="0B1727"/>
               </a:solidFill>
@@ -16423,7 +16388,11 @@
           <p:cNvSpPr>
             <a:spLocks noGrp="1"/>
           </p:cNvSpPr>
-          <p:nvPr/>
+          <p:nvPr>
+            <p:custDataLst>
+              <p:tags r:id="rId5"/>
+            </p:custDataLst>
+          </p:nvPr>
         </p:nvSpPr>
         <p:spPr>
           <a:xfrm>
@@ -16584,7 +16553,11 @@
           <p:cNvSpPr>
             <a:spLocks noGrp="1"/>
           </p:cNvSpPr>
-          <p:nvPr/>
+          <p:nvPr>
+            <p:custDataLst>
+              <p:tags r:id="rId6"/>
+            </p:custDataLst>
+          </p:nvPr>
         </p:nvSpPr>
         <p:spPr>
           <a:xfrm>
@@ -16743,11 +16716,15 @@
           <p:cNvSpPr>
             <a:spLocks noGrp="1"/>
           </p:cNvSpPr>
-          <p:nvPr/>
+          <p:nvPr>
+            <p:custDataLst>
+              <p:tags r:id="rId7"/>
+            </p:custDataLst>
+          </p:nvPr>
         </p:nvSpPr>
         <p:spPr>
           <a:xfrm>
-            <a:off x="4572000" y="4895850"/>
+            <a:off x="4799965" y="5085080"/>
             <a:ext cx="3048000" cy="647700"/>
           </a:xfrm>
           <a:prstGeom prst="rect">
@@ -16875,7 +16852,7 @@
               </a:defRPr>
             </a:pPr>
             <a:r>
-              <a:rPr sz="1800" b="1">
+              <a:rPr lang="en-US" altLang="en-GB" sz="1800" b="1">
                 <a:solidFill>
                   <a:srgbClr val="0B1727"/>
                 </a:solidFill>
@@ -16883,9 +16860,9 @@
                 <a:ea typeface="Segoe UI" panose="020B0502040204020203"/>
                 <a:cs typeface="Segoe UI" panose="020B0502040204020203"/>
               </a:rPr>
-              <a:t>Product-specific</a:t>
+              <a:t>Make it adaptable</a:t>
             </a:r>
-            <a:endParaRPr sz="1800" b="1">
+            <a:endParaRPr lang="en-US" altLang="en-GB" sz="1800" b="1">
               <a:solidFill>
                 <a:srgbClr val="0B1727"/>
               </a:solidFill>
@@ -16906,7 +16883,7 @@
               </a:defRPr>
             </a:pPr>
             <a:r>
-              <a:rPr sz="1800" b="1">
+              <a:rPr lang="en-US" altLang="en-GB" sz="1800" b="1">
                 <a:solidFill>
                   <a:srgbClr val="0B1727"/>
                 </a:solidFill>
@@ -16914,9 +16891,9 @@
                 <a:ea typeface="Segoe UI" panose="020B0502040204020203"/>
                 <a:cs typeface="Segoe UI" panose="020B0502040204020203"/>
               </a:rPr>
-              <a:t>fit modules</a:t>
+              <a:t>Build institution-specific data adapters, setup tools and integration.</a:t>
             </a:r>
-            <a:endParaRPr sz="1800" b="1">
+            <a:endParaRPr lang="en-US" altLang="en-GB" sz="1800" b="1">
               <a:solidFill>
                 <a:srgbClr val="0B1727"/>
               </a:solidFill>
@@ -16933,7 +16910,11 @@
           <p:cNvSpPr>
             <a:spLocks noGrp="1"/>
           </p:cNvSpPr>
-          <p:nvPr/>
+          <p:nvPr>
+            <p:custDataLst>
+              <p:tags r:id="rId8"/>
+            </p:custDataLst>
+          </p:nvPr>
         </p:nvSpPr>
         <p:spPr>
           <a:xfrm>
@@ -17094,7 +17075,11 @@
           <p:cNvSpPr>
             <a:spLocks noGrp="1"/>
           </p:cNvSpPr>
-          <p:nvPr/>
+          <p:nvPr>
+            <p:custDataLst>
+              <p:tags r:id="rId9"/>
+            </p:custDataLst>
+          </p:nvPr>
         </p:nvSpPr>
         <p:spPr>
           <a:xfrm>
@@ -17253,11 +17238,15 @@
           <p:cNvSpPr>
             <a:spLocks noGrp="1"/>
           </p:cNvSpPr>
-          <p:nvPr/>
+          <p:nvPr>
+            <p:custDataLst>
+              <p:tags r:id="rId10"/>
+            </p:custDataLst>
+          </p:nvPr>
         </p:nvSpPr>
         <p:spPr>
           <a:xfrm>
-            <a:off x="8382000" y="4895850"/>
+            <a:off x="8420100" y="5091430"/>
             <a:ext cx="3048000" cy="647700"/>
           </a:xfrm>
           <a:prstGeom prst="rect">
@@ -17385,7 +17374,7 @@
               </a:defRPr>
             </a:pPr>
             <a:r>
-              <a:rPr sz="1800" b="1">
+              <a:rPr lang="en-US" altLang="en-GB" sz="1800" b="1">
                 <a:solidFill>
                   <a:srgbClr val="0B1727"/>
                 </a:solidFill>
@@ -17393,40 +17382,9 @@
                 <a:ea typeface="Segoe UI" panose="020B0502040204020203"/>
                 <a:cs typeface="Segoe UI" panose="020B0502040204020203"/>
               </a:rPr>
-              <a:t>Shadow pilot</a:t>
+              <a:t>Test the SDK with a bank or fintech in a controlled pilot, using approved data and measured outcomes.</a:t>
             </a:r>
-            <a:endParaRPr sz="1800" b="1">
-              <a:solidFill>
-                <a:srgbClr val="0B1727"/>
-              </a:solidFill>
-              <a:latin typeface="Segoe UI" panose="020B0502040204020203"/>
-              <a:ea typeface="Segoe UI" panose="020B0502040204020203"/>
-              <a:cs typeface="Segoe UI" panose="020B0502040204020203"/>
-            </a:endParaRPr>
-          </a:p>
-          <a:p>
-            <a:pPr algn="ctr">
-              <a:defRPr sz="1800" b="1">
-                <a:solidFill>
-                  <a:srgbClr val="0B1727"/>
-                </a:solidFill>
-                <a:latin typeface="Segoe UI" panose="020B0502040204020203"/>
-                <a:ea typeface="Segoe UI" panose="020B0502040204020203"/>
-                <a:cs typeface="Segoe UI" panose="020B0502040204020203"/>
-              </a:defRPr>
-            </a:pPr>
-            <a:r>
-              <a:rPr sz="1800" b="1">
-                <a:solidFill>
-                  <a:srgbClr val="0B1727"/>
-                </a:solidFill>
-                <a:latin typeface="Segoe UI" panose="020B0502040204020203"/>
-                <a:ea typeface="Segoe UI" panose="020B0502040204020203"/>
-                <a:cs typeface="Segoe UI" panose="020B0502040204020203"/>
-              </a:rPr>
-              <a:t>+ measurement</a:t>
-            </a:r>
-            <a:endParaRPr sz="1800" b="1">
+            <a:endParaRPr lang="en-US" altLang="en-GB" sz="1800" b="1">
               <a:solidFill>
                 <a:srgbClr val="0B1727"/>
               </a:solidFill>
@@ -17631,6 +17589,66 @@
     <a:masterClrMapping/>
   </p:clrMapOvr>
 </p:sld>
+</file>
+
+<file path=ppt/tags/tag1.xml><?xml version="1.0" encoding="utf-8"?>
+<p:tagLst xmlns:p="http://schemas.openxmlformats.org/presentationml/2006/main">
+  <p:tag name="KSO_WM_DIAGRAM_VIRTUALLY_FRAME" val="{&quot;height&quot;:172.9,&quot;left&quot;:60,&quot;top&quot;:295.5,&quot;width&quot;:844.5}"/>
+</p:tagLst>
+</file>
+
+<file path=ppt/tags/tag10.xml><?xml version="1.0" encoding="utf-8"?>
+<p:tagLst xmlns:p="http://schemas.openxmlformats.org/presentationml/2006/main">
+  <p:tag name="KSO_WM_DIAGRAM_VIRTUALLY_FRAME" val="{&quot;height&quot;:172.9,&quot;left&quot;:60,&quot;top&quot;:295.5,&quot;width&quot;:844.5}"/>
+</p:tagLst>
+</file>
+
+<file path=ppt/tags/tag2.xml><?xml version="1.0" encoding="utf-8"?>
+<p:tagLst xmlns:p="http://schemas.openxmlformats.org/presentationml/2006/main">
+  <p:tag name="KSO_WM_DIAGRAM_VIRTUALLY_FRAME" val="{&quot;height&quot;:172.9,&quot;left&quot;:60,&quot;top&quot;:295.5,&quot;width&quot;:844.5}"/>
+</p:tagLst>
+</file>
+
+<file path=ppt/tags/tag3.xml><?xml version="1.0" encoding="utf-8"?>
+<p:tagLst xmlns:p="http://schemas.openxmlformats.org/presentationml/2006/main">
+  <p:tag name="KSO_WM_DIAGRAM_VIRTUALLY_FRAME" val="{&quot;height&quot;:172.9,&quot;left&quot;:60,&quot;top&quot;:295.5,&quot;width&quot;:844.5}"/>
+</p:tagLst>
+</file>
+
+<file path=ppt/tags/tag4.xml><?xml version="1.0" encoding="utf-8"?>
+<p:tagLst xmlns:p="http://schemas.openxmlformats.org/presentationml/2006/main">
+  <p:tag name="KSO_WM_DIAGRAM_VIRTUALLY_FRAME" val="{&quot;height&quot;:172.9,&quot;left&quot;:60,&quot;top&quot;:295.5,&quot;width&quot;:844.5}"/>
+</p:tagLst>
+</file>
+
+<file path=ppt/tags/tag5.xml><?xml version="1.0" encoding="utf-8"?>
+<p:tagLst xmlns:p="http://schemas.openxmlformats.org/presentationml/2006/main">
+  <p:tag name="KSO_WM_DIAGRAM_VIRTUALLY_FRAME" val="{&quot;height&quot;:172.9,&quot;left&quot;:60,&quot;top&quot;:295.5,&quot;width&quot;:844.5}"/>
+</p:tagLst>
+</file>
+
+<file path=ppt/tags/tag6.xml><?xml version="1.0" encoding="utf-8"?>
+<p:tagLst xmlns:p="http://schemas.openxmlformats.org/presentationml/2006/main">
+  <p:tag name="KSO_WM_DIAGRAM_VIRTUALLY_FRAME" val="{&quot;height&quot;:172.9,&quot;left&quot;:60,&quot;top&quot;:295.5,&quot;width&quot;:844.5}"/>
+</p:tagLst>
+</file>
+
+<file path=ppt/tags/tag7.xml><?xml version="1.0" encoding="utf-8"?>
+<p:tagLst xmlns:p="http://schemas.openxmlformats.org/presentationml/2006/main">
+  <p:tag name="KSO_WM_DIAGRAM_VIRTUALLY_FRAME" val="{&quot;height&quot;:172.9,&quot;left&quot;:60,&quot;top&quot;:295.5,&quot;width&quot;:844.5}"/>
+</p:tagLst>
+</file>
+
+<file path=ppt/tags/tag8.xml><?xml version="1.0" encoding="utf-8"?>
+<p:tagLst xmlns:p="http://schemas.openxmlformats.org/presentationml/2006/main">
+  <p:tag name="KSO_WM_DIAGRAM_VIRTUALLY_FRAME" val="{&quot;height&quot;:172.9,&quot;left&quot;:60,&quot;top&quot;:295.5,&quot;width&quot;:844.5}"/>
+</p:tagLst>
+</file>
+
+<file path=ppt/tags/tag9.xml><?xml version="1.0" encoding="utf-8"?>
+<p:tagLst xmlns:p="http://schemas.openxmlformats.org/presentationml/2006/main">
+  <p:tag name="KSO_WM_DIAGRAM_VIRTUALLY_FRAME" val="{&quot;height&quot;:172.9,&quot;left&quot;:60,&quot;top&quot;:295.5,&quot;width&quot;:844.5}"/>
+</p:tagLst>
 </file>
 
 <file path=ppt/theme/theme1.xml><?xml version="1.0" encoding="utf-8"?>

</xml_diff>